<commit_message>
pptx: add NetSuite connector content across all slides
- Slide 1: add NetSuite ERP to platform description
- Slide 2: add NetSuite row to problem table; update '3→4 disconnected views'
- Slide 3: add NetSuite to Multi-Source Connectors card; stats '4→5 sources'
- Slide 4: remove '(NetSuite — roadmap)'; list as full source system
- Slide 5: NetSuite card active=true, amber, correct OAuth 1.0a TBA / SuiteQL body
- Slide 8: add NetSuite Customer as 4th entity-resolution source box
- Slide 13: add NetSuite row to live data table (Built / ready)
- Slide 16: roadmap Now lane notes connector code-complete; backlog updated
- Slide 17: update closing bullet to 'five source connectors'
</commit_message>
<xml_diff>
--- a/Enterprise_Data_Lake_Platform_v2.pptx
+++ b/Enterprise_Data_Lake_Platform_v2.pptx
@@ -3279,7 +3279,7 @@
                 </a:solidFill>
                 <a:latin typeface="Open Sauce"/>
               </a:rPr>
-              <a:t>A unified platform connecting Salesforce CRM, MySQL RDS, and Sage ERP
+              <a:t>A unified platform connecting Salesforce CRM, MySQL RDS, Sage ERP, and NetSuite ERP
 into a single trusted, analytics-ready data foundation — built on AWS.</a:t>
             </a:r>
           </a:p>
@@ -9592,7 +9592,397 @@
       </p:sp>
       <p:sp>
         <p:nvSpPr>
-          <p:cNvPr id="84" name="TextBox 83"/>
+          <p:cNvPr id="84" name="Rectangle 83"/>
+          <p:cNvSpPr/>
+          <p:nvPr/>
+        </p:nvSpPr>
+        <p:spPr>
+          <a:xfrm>
+            <a:off x="502920" y="5943600"/>
+            <a:ext cx="2423160" cy="384048"/>
+          </a:xfrm>
+          <a:prstGeom prst="rect">
+            <a:avLst/>
+          </a:prstGeom>
+          <a:solidFill>
+            <a:srgbClr val="F8F8F8"/>
+          </a:solidFill>
+          <a:ln>
+            <a:noFill/>
+          </a:ln>
+        </p:spPr>
+        <p:style>
+          <a:lnRef idx="1">
+            <a:schemeClr val="accent1"/>
+          </a:lnRef>
+          <a:fillRef idx="3">
+            <a:schemeClr val="accent1"/>
+          </a:fillRef>
+          <a:effectRef idx="2">
+            <a:schemeClr val="accent1"/>
+          </a:effectRef>
+          <a:fontRef idx="minor">
+            <a:schemeClr val="lt1"/>
+          </a:fontRef>
+        </p:style>
+        <p:txBody>
+          <a:bodyPr rtlCol="0" anchor="ctr"/>
+          <a:lstStyle/>
+          <a:p>
+            <a:pPr algn="ctr"/>
+          </a:p>
+        </p:txBody>
+      </p:sp>
+      <p:sp>
+        <p:nvSpPr>
+          <p:cNvPr id="85" name="TextBox 84"/>
+          <p:cNvSpPr txBox="1"/>
+          <p:nvPr/>
+        </p:nvSpPr>
+        <p:spPr>
+          <a:xfrm>
+            <a:off x="566928" y="5998464"/>
+            <a:ext cx="2331720" cy="310896"/>
+          </a:xfrm>
+          <a:prstGeom prst="rect">
+            <a:avLst/>
+          </a:prstGeom>
+          <a:noFill/>
+        </p:spPr>
+        <p:txBody>
+          <a:bodyPr wrap="square">
+            <a:spAutoFit/>
+          </a:bodyPr>
+          <a:lstStyle/>
+          <a:p>
+            <a:pPr algn="l"/>
+            <a:r>
+              <a:rPr sz="1100" b="0" i="0">
+                <a:solidFill>
+                  <a:srgbClr val="222222"/>
+                </a:solidFill>
+                <a:latin typeface="Open Sauce"/>
+              </a:rPr>
+              <a:t>NetSuite — Customer</a:t>
+            </a:r>
+          </a:p>
+        </p:txBody>
+      </p:sp>
+      <p:sp>
+        <p:nvSpPr>
+          <p:cNvPr id="86" name="Rectangle 85"/>
+          <p:cNvSpPr/>
+          <p:nvPr/>
+        </p:nvSpPr>
+        <p:spPr>
+          <a:xfrm>
+            <a:off x="2926080" y="5943600"/>
+            <a:ext cx="1600200" cy="384048"/>
+          </a:xfrm>
+          <a:prstGeom prst="rect">
+            <a:avLst/>
+          </a:prstGeom>
+          <a:solidFill>
+            <a:srgbClr val="F8F8F8"/>
+          </a:solidFill>
+          <a:ln>
+            <a:noFill/>
+          </a:ln>
+        </p:spPr>
+        <p:style>
+          <a:lnRef idx="1">
+            <a:schemeClr val="accent1"/>
+          </a:lnRef>
+          <a:fillRef idx="3">
+            <a:schemeClr val="accent1"/>
+          </a:fillRef>
+          <a:effectRef idx="2">
+            <a:schemeClr val="accent1"/>
+          </a:effectRef>
+          <a:fontRef idx="minor">
+            <a:schemeClr val="lt1"/>
+          </a:fontRef>
+        </p:style>
+        <p:txBody>
+          <a:bodyPr rtlCol="0" anchor="ctr"/>
+          <a:lstStyle/>
+          <a:p>
+            <a:pPr algn="ctr"/>
+          </a:p>
+        </p:txBody>
+      </p:sp>
+      <p:sp>
+        <p:nvSpPr>
+          <p:cNvPr id="87" name="TextBox 86"/>
+          <p:cNvSpPr txBox="1"/>
+          <p:nvPr/>
+        </p:nvSpPr>
+        <p:spPr>
+          <a:xfrm>
+            <a:off x="2990088" y="5998464"/>
+            <a:ext cx="1508760" cy="310896"/>
+          </a:xfrm>
+          <a:prstGeom prst="rect">
+            <a:avLst/>
+          </a:prstGeom>
+          <a:noFill/>
+        </p:spPr>
+        <p:txBody>
+          <a:bodyPr wrap="square">
+            <a:spAutoFit/>
+          </a:bodyPr>
+          <a:lstStyle/>
+          <a:p>
+            <a:pPr algn="l"/>
+            <a:r>
+              <a:rPr sz="1100" b="0" i="0">
+                <a:solidFill>
+                  <a:srgbClr val="222222"/>
+                </a:solidFill>
+                <a:latin typeface="Open Sauce"/>
+              </a:rPr>
+              <a:t>Incremental (SCD1)</a:t>
+            </a:r>
+          </a:p>
+        </p:txBody>
+      </p:sp>
+      <p:sp>
+        <p:nvSpPr>
+          <p:cNvPr id="88" name="Rectangle 87"/>
+          <p:cNvSpPr/>
+          <p:nvPr/>
+        </p:nvSpPr>
+        <p:spPr>
+          <a:xfrm>
+            <a:off x="4526280" y="5943600"/>
+            <a:ext cx="1371600" cy="384048"/>
+          </a:xfrm>
+          <a:prstGeom prst="rect">
+            <a:avLst/>
+          </a:prstGeom>
+          <a:solidFill>
+            <a:srgbClr val="F8F8F8"/>
+          </a:solidFill>
+          <a:ln>
+            <a:noFill/>
+          </a:ln>
+        </p:spPr>
+        <p:style>
+          <a:lnRef idx="1">
+            <a:schemeClr val="accent1"/>
+          </a:lnRef>
+          <a:fillRef idx="3">
+            <a:schemeClr val="accent1"/>
+          </a:fillRef>
+          <a:effectRef idx="2">
+            <a:schemeClr val="accent1"/>
+          </a:effectRef>
+          <a:fontRef idx="minor">
+            <a:schemeClr val="lt1"/>
+          </a:fontRef>
+        </p:style>
+        <p:txBody>
+          <a:bodyPr rtlCol="0" anchor="ctr"/>
+          <a:lstStyle/>
+          <a:p>
+            <a:pPr algn="ctr"/>
+          </a:p>
+        </p:txBody>
+      </p:sp>
+      <p:sp>
+        <p:nvSpPr>
+          <p:cNvPr id="89" name="TextBox 88"/>
+          <p:cNvSpPr txBox="1"/>
+          <p:nvPr/>
+        </p:nvSpPr>
+        <p:spPr>
+          <a:xfrm>
+            <a:off x="4590288" y="5998464"/>
+            <a:ext cx="1280160" cy="310896"/>
+          </a:xfrm>
+          <a:prstGeom prst="rect">
+            <a:avLst/>
+          </a:prstGeom>
+          <a:noFill/>
+        </p:spPr>
+        <p:txBody>
+          <a:bodyPr wrap="square">
+            <a:spAutoFit/>
+          </a:bodyPr>
+          <a:lstStyle/>
+          <a:p>
+            <a:pPr algn="l"/>
+            <a:r>
+              <a:rPr sz="1100" b="0" i="0">
+                <a:solidFill>
+                  <a:srgbClr val="222222"/>
+                </a:solidFill>
+                <a:latin typeface="Open Sauce"/>
+              </a:rPr>
+              <a:t>Built</a:t>
+            </a:r>
+          </a:p>
+        </p:txBody>
+      </p:sp>
+      <p:sp>
+        <p:nvSpPr>
+          <p:cNvPr id="90" name="Rectangle 89"/>
+          <p:cNvSpPr/>
+          <p:nvPr/>
+        </p:nvSpPr>
+        <p:spPr>
+          <a:xfrm>
+            <a:off x="5897880" y="5943600"/>
+            <a:ext cx="2560320" cy="384048"/>
+          </a:xfrm>
+          <a:prstGeom prst="rect">
+            <a:avLst/>
+          </a:prstGeom>
+          <a:solidFill>
+            <a:srgbClr val="F8F8F8"/>
+          </a:solidFill>
+          <a:ln>
+            <a:noFill/>
+          </a:ln>
+        </p:spPr>
+        <p:style>
+          <a:lnRef idx="1">
+            <a:schemeClr val="accent1"/>
+          </a:lnRef>
+          <a:fillRef idx="3">
+            <a:schemeClr val="accent1"/>
+          </a:fillRef>
+          <a:effectRef idx="2">
+            <a:schemeClr val="accent1"/>
+          </a:effectRef>
+          <a:fontRef idx="minor">
+            <a:schemeClr val="lt1"/>
+          </a:fontRef>
+        </p:style>
+        <p:txBody>
+          <a:bodyPr rtlCol="0" anchor="ctr"/>
+          <a:lstStyle/>
+          <a:p>
+            <a:pPr algn="ctr"/>
+          </a:p>
+        </p:txBody>
+      </p:sp>
+      <p:sp>
+        <p:nvSpPr>
+          <p:cNvPr id="91" name="TextBox 90"/>
+          <p:cNvSpPr txBox="1"/>
+          <p:nvPr/>
+        </p:nvSpPr>
+        <p:spPr>
+          <a:xfrm>
+            <a:off x="5961888" y="5998464"/>
+            <a:ext cx="2468880" cy="310896"/>
+          </a:xfrm>
+          <a:prstGeom prst="rect">
+            <a:avLst/>
+          </a:prstGeom>
+          <a:noFill/>
+        </p:spPr>
+        <p:txBody>
+          <a:bodyPr wrap="square">
+            <a:spAutoFit/>
+          </a:bodyPr>
+          <a:lstStyle/>
+          <a:p>
+            <a:pPr algn="l"/>
+            <a:r>
+              <a:rPr sz="1100" b="0" i="0">
+                <a:solidFill>
+                  <a:srgbClr val="222222"/>
+                </a:solidFill>
+                <a:latin typeface="Open Sauce"/>
+              </a:rPr>
+              <a:t>dev_edl_analytics.company (ready)</a:t>
+            </a:r>
+          </a:p>
+        </p:txBody>
+      </p:sp>
+      <p:sp>
+        <p:nvSpPr>
+          <p:cNvPr id="92" name="Rectangle 91"/>
+          <p:cNvSpPr/>
+          <p:nvPr/>
+        </p:nvSpPr>
+        <p:spPr>
+          <a:xfrm>
+            <a:off x="8458200" y="5943600"/>
+            <a:ext cx="621792" cy="384048"/>
+          </a:xfrm>
+          <a:prstGeom prst="rect">
+            <a:avLst/>
+          </a:prstGeom>
+          <a:solidFill>
+            <a:srgbClr val="F8F8F8"/>
+          </a:solidFill>
+          <a:ln>
+            <a:noFill/>
+          </a:ln>
+        </p:spPr>
+        <p:style>
+          <a:lnRef idx="1">
+            <a:schemeClr val="accent1"/>
+          </a:lnRef>
+          <a:fillRef idx="3">
+            <a:schemeClr val="accent1"/>
+          </a:fillRef>
+          <a:effectRef idx="2">
+            <a:schemeClr val="accent1"/>
+          </a:effectRef>
+          <a:fontRef idx="minor">
+            <a:schemeClr val="lt1"/>
+          </a:fontRef>
+        </p:style>
+        <p:txBody>
+          <a:bodyPr rtlCol="0" anchor="ctr"/>
+          <a:lstStyle/>
+          <a:p>
+            <a:pPr algn="ctr"/>
+          </a:p>
+        </p:txBody>
+      </p:sp>
+      <p:sp>
+        <p:nvSpPr>
+          <p:cNvPr id="93" name="TextBox 92"/>
+          <p:cNvSpPr txBox="1"/>
+          <p:nvPr/>
+        </p:nvSpPr>
+        <p:spPr>
+          <a:xfrm>
+            <a:off x="8522208" y="5998464"/>
+            <a:ext cx="530352" cy="310896"/>
+          </a:xfrm>
+          <a:prstGeom prst="rect">
+            <a:avLst/>
+          </a:prstGeom>
+          <a:noFill/>
+        </p:spPr>
+        <p:txBody>
+          <a:bodyPr wrap="square">
+            <a:spAutoFit/>
+          </a:bodyPr>
+          <a:lstStyle/>
+          <a:p>
+            <a:pPr algn="l"/>
+            <a:r>
+              <a:rPr sz="1100" b="0" i="0">
+                <a:solidFill>
+                  <a:srgbClr val="222222"/>
+                </a:solidFill>
+                <a:latin typeface="Open Sauce"/>
+              </a:rPr>
+              <a:t>🔲</a:t>
+            </a:r>
+          </a:p>
+        </p:txBody>
+      </p:sp>
+      <p:sp>
+        <p:nvSpPr>
+          <p:cNvPr id="94" name="TextBox 93"/>
           <p:cNvSpPr txBox="1"/>
           <p:nvPr/>
         </p:nvSpPr>
@@ -9627,7 +10017,7 @@
       </p:sp>
       <p:sp>
         <p:nvSpPr>
-          <p:cNvPr id="85" name="TextBox 84"/>
+          <p:cNvPr id="95" name="TextBox 94"/>
           <p:cNvSpPr txBox="1"/>
           <p:nvPr/>
         </p:nvSpPr>
@@ -13556,7 +13946,7 @@
         <p:spPr>
           <a:xfrm>
             <a:off x="612648" y="2167128"/>
-            <a:ext cx="2023110" cy="630936"/>
+            <a:ext cx="2023110" cy="532964"/>
           </a:xfrm>
           <a:prstGeom prst="rect">
             <a:avLst/>
@@ -13590,8 +13980,8 @@
         </p:nvSpPr>
         <p:spPr>
           <a:xfrm>
-            <a:off x="612648" y="2852928"/>
-            <a:ext cx="2023110" cy="630936"/>
+            <a:off x="612648" y="2754956"/>
+            <a:ext cx="2023110" cy="532964"/>
           </a:xfrm>
           <a:prstGeom prst="rect">
             <a:avLst/>
@@ -13612,7 +14002,7 @@
                 </a:solidFill>
                 <a:latin typeface="Open Sauce"/>
               </a:rPr>
-              <a:t>▸  3 sources: Salesforce, MySQL, Sage</a:t>
+              <a:t>▸  4 sources live: Salesforce, MySQL, Sage</a:t>
             </a:r>
           </a:p>
         </p:txBody>
@@ -13625,8 +14015,8 @@
         </p:nvSpPr>
         <p:spPr>
           <a:xfrm>
-            <a:off x="612648" y="3538728"/>
-            <a:ext cx="2023110" cy="630936"/>
+            <a:off x="612648" y="3342785"/>
+            <a:ext cx="2023110" cy="532964"/>
           </a:xfrm>
           <a:prstGeom prst="rect">
             <a:avLst/>
@@ -13647,6 +14037,41 @@
                 </a:solidFill>
                 <a:latin typeface="Open Sauce"/>
               </a:rPr>
+              <a:t>▸  NetSuite connector code-complete</a:t>
+            </a:r>
+          </a:p>
+        </p:txBody>
+      </p:sp>
+      <p:sp>
+        <p:nvSpPr>
+          <p:cNvPr id="12" name="TextBox 11"/>
+          <p:cNvSpPr txBox="1"/>
+          <p:nvPr/>
+        </p:nvSpPr>
+        <p:spPr>
+          <a:xfrm>
+            <a:off x="612648" y="3930613"/>
+            <a:ext cx="2023110" cy="532964"/>
+          </a:xfrm>
+          <a:prstGeom prst="rect">
+            <a:avLst/>
+          </a:prstGeom>
+          <a:noFill/>
+        </p:spPr>
+        <p:txBody>
+          <a:bodyPr wrap="square">
+            <a:spAutoFit/>
+          </a:bodyPr>
+          <a:lstStyle/>
+          <a:p>
+            <a:pPr algn="l"/>
+            <a:r>
+              <a:rPr sz="1200" b="0" i="0">
+                <a:solidFill>
+                  <a:srgbClr val="222222"/>
+                </a:solidFill>
+                <a:latin typeface="Open Sauce"/>
+              </a:rPr>
               <a:t>▸  35,971+ records in analytics layer</a:t>
             </a:r>
           </a:p>
@@ -13654,14 +14079,14 @@
       </p:sp>
       <p:sp>
         <p:nvSpPr>
-          <p:cNvPr id="12" name="TextBox 11"/>
-          <p:cNvSpPr txBox="1"/>
-          <p:nvPr/>
-        </p:nvSpPr>
-        <p:spPr>
-          <a:xfrm>
-            <a:off x="612648" y="4224528"/>
-            <a:ext cx="2023110" cy="630936"/>
+          <p:cNvPr id="13" name="TextBox 12"/>
+          <p:cNvSpPr txBox="1"/>
+          <p:nvPr/>
+        </p:nvSpPr>
+        <p:spPr>
+          <a:xfrm>
+            <a:off x="612648" y="4518442"/>
+            <a:ext cx="2023110" cy="532964"/>
           </a:xfrm>
           <a:prstGeom prst="rect">
             <a:avLst/>
@@ -13689,14 +14114,14 @@
       </p:sp>
       <p:sp>
         <p:nvSpPr>
-          <p:cNvPr id="13" name="TextBox 12"/>
-          <p:cNvSpPr txBox="1"/>
-          <p:nvPr/>
-        </p:nvSpPr>
-        <p:spPr>
-          <a:xfrm>
-            <a:off x="612648" y="4910328"/>
-            <a:ext cx="2023110" cy="630936"/>
+          <p:cNvPr id="14" name="TextBox 13"/>
+          <p:cNvSpPr txBox="1"/>
+          <p:nvPr/>
+        </p:nvSpPr>
+        <p:spPr>
+          <a:xfrm>
+            <a:off x="612648" y="5106270"/>
+            <a:ext cx="2023110" cy="532964"/>
           </a:xfrm>
           <a:prstGeom prst="rect">
             <a:avLst/>
@@ -13724,14 +14149,14 @@
       </p:sp>
       <p:sp>
         <p:nvSpPr>
-          <p:cNvPr id="14" name="TextBox 13"/>
-          <p:cNvSpPr txBox="1"/>
-          <p:nvPr/>
-        </p:nvSpPr>
-        <p:spPr>
-          <a:xfrm>
-            <a:off x="612648" y="5596128"/>
-            <a:ext cx="2023110" cy="630936"/>
+          <p:cNvPr id="15" name="TextBox 14"/>
+          <p:cNvSpPr txBox="1"/>
+          <p:nvPr/>
+        </p:nvSpPr>
+        <p:spPr>
+          <a:xfrm>
+            <a:off x="612648" y="5694099"/>
+            <a:ext cx="2023110" cy="532964"/>
           </a:xfrm>
           <a:prstGeom prst="rect">
             <a:avLst/>
@@ -13759,7 +14184,7 @@
       </p:sp>
       <p:sp>
         <p:nvSpPr>
-          <p:cNvPr id="15" name="Rectangle 14"/>
+          <p:cNvPr id="16" name="Rectangle 15"/>
           <p:cNvSpPr/>
           <p:nvPr/>
         </p:nvSpPr>
@@ -13802,7 +14227,7 @@
       </p:sp>
       <p:sp>
         <p:nvSpPr>
-          <p:cNvPr id="16" name="TextBox 15"/>
+          <p:cNvPr id="17" name="TextBox 16"/>
           <p:cNvSpPr txBox="1"/>
           <p:nvPr/>
         </p:nvSpPr>
@@ -13837,7 +14262,7 @@
       </p:sp>
       <p:sp>
         <p:nvSpPr>
-          <p:cNvPr id="17" name="Rectangle 16"/>
+          <p:cNvPr id="18" name="Rectangle 17"/>
           <p:cNvSpPr/>
           <p:nvPr/>
         </p:nvSpPr>
@@ -13882,7 +14307,7 @@
       </p:sp>
       <p:sp>
         <p:nvSpPr>
-          <p:cNvPr id="18" name="TextBox 17"/>
+          <p:cNvPr id="19" name="TextBox 18"/>
           <p:cNvSpPr txBox="1"/>
           <p:nvPr/>
         </p:nvSpPr>
@@ -13917,7 +14342,7 @@
       </p:sp>
       <p:sp>
         <p:nvSpPr>
-          <p:cNvPr id="19" name="TextBox 18"/>
+          <p:cNvPr id="20" name="TextBox 19"/>
           <p:cNvSpPr txBox="1"/>
           <p:nvPr/>
         </p:nvSpPr>
@@ -13952,7 +14377,7 @@
       </p:sp>
       <p:sp>
         <p:nvSpPr>
-          <p:cNvPr id="20" name="TextBox 19"/>
+          <p:cNvPr id="21" name="TextBox 20"/>
           <p:cNvSpPr txBox="1"/>
           <p:nvPr/>
         </p:nvSpPr>
@@ -13987,7 +14412,7 @@
       </p:sp>
       <p:sp>
         <p:nvSpPr>
-          <p:cNvPr id="21" name="TextBox 20"/>
+          <p:cNvPr id="22" name="TextBox 21"/>
           <p:cNvSpPr txBox="1"/>
           <p:nvPr/>
         </p:nvSpPr>
@@ -14022,7 +14447,7 @@
       </p:sp>
       <p:sp>
         <p:nvSpPr>
-          <p:cNvPr id="22" name="TextBox 21"/>
+          <p:cNvPr id="23" name="TextBox 22"/>
           <p:cNvSpPr txBox="1"/>
           <p:nvPr/>
         </p:nvSpPr>
@@ -14057,7 +14482,7 @@
       </p:sp>
       <p:sp>
         <p:nvSpPr>
-          <p:cNvPr id="23" name="TextBox 22"/>
+          <p:cNvPr id="24" name="TextBox 23"/>
           <p:cNvSpPr txBox="1"/>
           <p:nvPr/>
         </p:nvSpPr>
@@ -14092,7 +14517,7 @@
       </p:sp>
       <p:sp>
         <p:nvSpPr>
-          <p:cNvPr id="24" name="Rectangle 23"/>
+          <p:cNvPr id="25" name="Rectangle 24"/>
           <p:cNvSpPr/>
           <p:nvPr/>
         </p:nvSpPr>
@@ -14135,7 +14560,7 @@
       </p:sp>
       <p:sp>
         <p:nvSpPr>
-          <p:cNvPr id="25" name="TextBox 24"/>
+          <p:cNvPr id="26" name="TextBox 25"/>
           <p:cNvSpPr txBox="1"/>
           <p:nvPr/>
         </p:nvSpPr>
@@ -14170,7 +14595,7 @@
       </p:sp>
       <p:sp>
         <p:nvSpPr>
-          <p:cNvPr id="26" name="Rectangle 25"/>
+          <p:cNvPr id="27" name="Rectangle 26"/>
           <p:cNvSpPr/>
           <p:nvPr/>
         </p:nvSpPr>
@@ -14215,7 +14640,7 @@
       </p:sp>
       <p:sp>
         <p:nvSpPr>
-          <p:cNvPr id="27" name="TextBox 26"/>
+          <p:cNvPr id="28" name="TextBox 27"/>
           <p:cNvSpPr txBox="1"/>
           <p:nvPr/>
         </p:nvSpPr>
@@ -14250,7 +14675,7 @@
       </p:sp>
       <p:sp>
         <p:nvSpPr>
-          <p:cNvPr id="28" name="TextBox 27"/>
+          <p:cNvPr id="29" name="TextBox 28"/>
           <p:cNvSpPr txBox="1"/>
           <p:nvPr/>
         </p:nvSpPr>
@@ -14285,7 +14710,7 @@
       </p:sp>
       <p:sp>
         <p:nvSpPr>
-          <p:cNvPr id="29" name="TextBox 28"/>
+          <p:cNvPr id="30" name="TextBox 29"/>
           <p:cNvSpPr txBox="1"/>
           <p:nvPr/>
         </p:nvSpPr>
@@ -14320,7 +14745,7 @@
       </p:sp>
       <p:sp>
         <p:nvSpPr>
-          <p:cNvPr id="30" name="TextBox 29"/>
+          <p:cNvPr id="31" name="TextBox 30"/>
           <p:cNvSpPr txBox="1"/>
           <p:nvPr/>
         </p:nvSpPr>
@@ -14355,7 +14780,7 @@
       </p:sp>
       <p:sp>
         <p:nvSpPr>
-          <p:cNvPr id="31" name="TextBox 30"/>
+          <p:cNvPr id="32" name="TextBox 31"/>
           <p:cNvSpPr txBox="1"/>
           <p:nvPr/>
         </p:nvSpPr>
@@ -14390,7 +14815,7 @@
       </p:sp>
       <p:sp>
         <p:nvSpPr>
-          <p:cNvPr id="32" name="TextBox 31"/>
+          <p:cNvPr id="33" name="TextBox 32"/>
           <p:cNvSpPr txBox="1"/>
           <p:nvPr/>
         </p:nvSpPr>
@@ -14425,7 +14850,7 @@
       </p:sp>
       <p:sp>
         <p:nvSpPr>
-          <p:cNvPr id="33" name="Rectangle 32"/>
+          <p:cNvPr id="34" name="Rectangle 33"/>
           <p:cNvSpPr/>
           <p:nvPr/>
         </p:nvSpPr>
@@ -14468,7 +14893,7 @@
       </p:sp>
       <p:sp>
         <p:nvSpPr>
-          <p:cNvPr id="34" name="TextBox 33"/>
+          <p:cNvPr id="35" name="TextBox 34"/>
           <p:cNvSpPr txBox="1"/>
           <p:nvPr/>
         </p:nvSpPr>
@@ -14503,7 +14928,7 @@
       </p:sp>
       <p:sp>
         <p:nvSpPr>
-          <p:cNvPr id="35" name="Rectangle 34"/>
+          <p:cNvPr id="36" name="Rectangle 35"/>
           <p:cNvSpPr/>
           <p:nvPr/>
         </p:nvSpPr>
@@ -14548,7 +14973,7 @@
       </p:sp>
       <p:sp>
         <p:nvSpPr>
-          <p:cNvPr id="36" name="TextBox 35"/>
+          <p:cNvPr id="37" name="TextBox 36"/>
           <p:cNvSpPr txBox="1"/>
           <p:nvPr/>
         </p:nvSpPr>
@@ -14576,14 +15001,14 @@
                 </a:solidFill>
                 <a:latin typeface="Open Sauce"/>
               </a:rPr>
-              <a:t>▸  NetSuite ERP connector</a:t>
-            </a:r>
-          </a:p>
-        </p:txBody>
-      </p:sp>
-      <p:sp>
-        <p:nvSpPr>
-          <p:cNvPr id="37" name="TextBox 36"/>
+              <a:t>▸  NetSuite — activate credentials &amp; go live</a:t>
+            </a:r>
+          </a:p>
+        </p:txBody>
+      </p:sp>
+      <p:sp>
+        <p:nvSpPr>
+          <p:cNvPr id="38" name="TextBox 37"/>
           <p:cNvSpPr txBox="1"/>
           <p:nvPr/>
         </p:nvSpPr>
@@ -14618,7 +15043,7 @@
       </p:sp>
       <p:sp>
         <p:nvSpPr>
-          <p:cNvPr id="38" name="TextBox 37"/>
+          <p:cNvPr id="39" name="TextBox 38"/>
           <p:cNvSpPr txBox="1"/>
           <p:nvPr/>
         </p:nvSpPr>
@@ -14653,7 +15078,7 @@
       </p:sp>
       <p:sp>
         <p:nvSpPr>
-          <p:cNvPr id="39" name="TextBox 38"/>
+          <p:cNvPr id="40" name="TextBox 39"/>
           <p:cNvSpPr txBox="1"/>
           <p:nvPr/>
         </p:nvSpPr>
@@ -14688,7 +15113,7 @@
       </p:sp>
       <p:sp>
         <p:nvSpPr>
-          <p:cNvPr id="40" name="TextBox 39"/>
+          <p:cNvPr id="41" name="TextBox 40"/>
           <p:cNvSpPr txBox="1"/>
           <p:nvPr/>
         </p:nvSpPr>
@@ -14723,7 +15148,7 @@
       </p:sp>
       <p:sp>
         <p:nvSpPr>
-          <p:cNvPr id="41" name="TextBox 40"/>
+          <p:cNvPr id="42" name="TextBox 41"/>
           <p:cNvSpPr txBox="1"/>
           <p:nvPr/>
         </p:nvSpPr>
@@ -14758,7 +15183,7 @@
       </p:sp>
       <p:sp>
         <p:nvSpPr>
-          <p:cNvPr id="42" name="TextBox 41"/>
+          <p:cNvPr id="43" name="TextBox 42"/>
           <p:cNvSpPr txBox="1"/>
           <p:nvPr/>
         </p:nvSpPr>
@@ -15141,7 +15566,7 @@
                 </a:solidFill>
                 <a:latin typeface="Open Sauce"/>
               </a:rPr>
-              <a:t>Four connected sources — extensible to any REST or SQL source via config</a:t>
+              <a:t>Five source connectors — four live, NetSuite code-complete and ready to activate</a:t>
             </a:r>
           </a:p>
         </p:txBody>
@@ -17230,7 +17655,7 @@
                 </a:solidFill>
                 <a:latin typeface="Open Sauce"/>
               </a:rPr>
-              <a:t>All systems</a:t>
+              <a:t>NetSuite ERP</a:t>
             </a:r>
           </a:p>
         </p:txBody>
@@ -17308,7 +17733,7 @@
                 </a:solidFill>
                 <a:latin typeface="Open Sauce"/>
               </a:rPr>
-              <a:t>Credentials stored in scripts</a:t>
+              <a:t>Customers, transactions</a:t>
             </a:r>
           </a:p>
         </p:txBody>
@@ -17386,7 +17811,7 @@
                 </a:solidFill>
                 <a:latin typeface="Open Sauce"/>
               </a:rPr>
-              <a:t>Engineering</a:t>
+              <a:t>Finance, Ops</a:t>
             </a:r>
           </a:p>
         </p:txBody>
@@ -17464,7 +17889,7 @@
                 </a:solidFill>
                 <a:latin typeface="Open Sauce"/>
               </a:rPr>
-              <a:t>Security risk, no rotation</a:t>
+              <a:t>Siloed from CRM &amp; Sage data</a:t>
             </a:r>
           </a:p>
         </p:txBody>
@@ -17620,7 +18045,7 @@
                 </a:solidFill>
                 <a:latin typeface="Open Sauce"/>
               </a:rPr>
-              <a:t>Same customer = 3 records</a:t>
+              <a:t>Credentials stored in scripts</a:t>
             </a:r>
           </a:p>
         </p:txBody>
@@ -17698,7 +18123,7 @@
                 </a:solidFill>
                 <a:latin typeface="Open Sauce"/>
               </a:rPr>
-              <a:t>Analytics</a:t>
+              <a:t>Engineering</a:t>
             </a:r>
           </a:p>
         </p:txBody>
@@ -17776,7 +18201,7 @@
                 </a:solidFill>
                 <a:latin typeface="Open Sauce"/>
               </a:rPr>
-              <a:t>No single source of truth</a:t>
+              <a:t>Security risk, no rotation</a:t>
             </a:r>
           </a:p>
         </p:txBody>
@@ -17789,7 +18214,319 @@
         </p:nvSpPr>
         <p:spPr>
           <a:xfrm>
-            <a:off x="502920" y="4389120"/>
+            <a:off x="502920" y="4315968"/>
+            <a:ext cx="2240280" cy="457200"/>
+          </a:xfrm>
+          <a:prstGeom prst="rect">
+            <a:avLst/>
+          </a:prstGeom>
+          <a:solidFill>
+            <a:srgbClr val="F8F8F8"/>
+          </a:solidFill>
+          <a:ln>
+            <a:noFill/>
+          </a:ln>
+        </p:spPr>
+        <p:style>
+          <a:lnRef idx="1">
+            <a:schemeClr val="accent1"/>
+          </a:lnRef>
+          <a:fillRef idx="3">
+            <a:schemeClr val="accent1"/>
+          </a:fillRef>
+          <a:effectRef idx="2">
+            <a:schemeClr val="accent1"/>
+          </a:effectRef>
+          <a:fontRef idx="minor">
+            <a:schemeClr val="lt1"/>
+          </a:fontRef>
+        </p:style>
+        <p:txBody>
+          <a:bodyPr rtlCol="0" anchor="ctr"/>
+          <a:lstStyle/>
+          <a:p>
+            <a:pPr algn="ctr"/>
+          </a:p>
+        </p:txBody>
+      </p:sp>
+      <p:sp>
+        <p:nvSpPr>
+          <p:cNvPr id="55" name="TextBox 54"/>
+          <p:cNvSpPr txBox="1"/>
+          <p:nvPr/>
+        </p:nvSpPr>
+        <p:spPr>
+          <a:xfrm>
+            <a:off x="594360" y="4379976"/>
+            <a:ext cx="2103120" cy="365760"/>
+          </a:xfrm>
+          <a:prstGeom prst="rect">
+            <a:avLst/>
+          </a:prstGeom>
+          <a:noFill/>
+        </p:spPr>
+        <p:txBody>
+          <a:bodyPr wrap="square">
+            <a:spAutoFit/>
+          </a:bodyPr>
+          <a:lstStyle/>
+          <a:p>
+            <a:pPr algn="l"/>
+            <a:r>
+              <a:rPr sz="1150" b="0" i="0">
+                <a:solidFill>
+                  <a:srgbClr val="222222"/>
+                </a:solidFill>
+                <a:latin typeface="Open Sauce"/>
+              </a:rPr>
+              <a:t>All systems</a:t>
+            </a:r>
+          </a:p>
+        </p:txBody>
+      </p:sp>
+      <p:sp>
+        <p:nvSpPr>
+          <p:cNvPr id="56" name="Rectangle 55"/>
+          <p:cNvSpPr/>
+          <p:nvPr/>
+        </p:nvSpPr>
+        <p:spPr>
+          <a:xfrm>
+            <a:off x="2743200" y="4315968"/>
+            <a:ext cx="2240280" cy="457200"/>
+          </a:xfrm>
+          <a:prstGeom prst="rect">
+            <a:avLst/>
+          </a:prstGeom>
+          <a:solidFill>
+            <a:srgbClr val="F8F8F8"/>
+          </a:solidFill>
+          <a:ln>
+            <a:noFill/>
+          </a:ln>
+        </p:spPr>
+        <p:style>
+          <a:lnRef idx="1">
+            <a:schemeClr val="accent1"/>
+          </a:lnRef>
+          <a:fillRef idx="3">
+            <a:schemeClr val="accent1"/>
+          </a:fillRef>
+          <a:effectRef idx="2">
+            <a:schemeClr val="accent1"/>
+          </a:effectRef>
+          <a:fontRef idx="minor">
+            <a:schemeClr val="lt1"/>
+          </a:fontRef>
+        </p:style>
+        <p:txBody>
+          <a:bodyPr rtlCol="0" anchor="ctr"/>
+          <a:lstStyle/>
+          <a:p>
+            <a:pPr algn="ctr"/>
+          </a:p>
+        </p:txBody>
+      </p:sp>
+      <p:sp>
+        <p:nvSpPr>
+          <p:cNvPr id="57" name="TextBox 56"/>
+          <p:cNvSpPr txBox="1"/>
+          <p:nvPr/>
+        </p:nvSpPr>
+        <p:spPr>
+          <a:xfrm>
+            <a:off x="2834640" y="4379976"/>
+            <a:ext cx="2103120" cy="365760"/>
+          </a:xfrm>
+          <a:prstGeom prst="rect">
+            <a:avLst/>
+          </a:prstGeom>
+          <a:noFill/>
+        </p:spPr>
+        <p:txBody>
+          <a:bodyPr wrap="square">
+            <a:spAutoFit/>
+          </a:bodyPr>
+          <a:lstStyle/>
+          <a:p>
+            <a:pPr algn="l"/>
+            <a:r>
+              <a:rPr sz="1150" b="0" i="0">
+                <a:solidFill>
+                  <a:srgbClr val="222222"/>
+                </a:solidFill>
+                <a:latin typeface="Open Sauce"/>
+              </a:rPr>
+              <a:t>Same customer = 4 records</a:t>
+            </a:r>
+          </a:p>
+        </p:txBody>
+      </p:sp>
+      <p:sp>
+        <p:nvSpPr>
+          <p:cNvPr id="58" name="Rectangle 57"/>
+          <p:cNvSpPr/>
+          <p:nvPr/>
+        </p:nvSpPr>
+        <p:spPr>
+          <a:xfrm>
+            <a:off x="4983480" y="4315968"/>
+            <a:ext cx="2148840" cy="457200"/>
+          </a:xfrm>
+          <a:prstGeom prst="rect">
+            <a:avLst/>
+          </a:prstGeom>
+          <a:solidFill>
+            <a:srgbClr val="F8F8F8"/>
+          </a:solidFill>
+          <a:ln>
+            <a:noFill/>
+          </a:ln>
+        </p:spPr>
+        <p:style>
+          <a:lnRef idx="1">
+            <a:schemeClr val="accent1"/>
+          </a:lnRef>
+          <a:fillRef idx="3">
+            <a:schemeClr val="accent1"/>
+          </a:fillRef>
+          <a:effectRef idx="2">
+            <a:schemeClr val="accent1"/>
+          </a:effectRef>
+          <a:fontRef idx="minor">
+            <a:schemeClr val="lt1"/>
+          </a:fontRef>
+        </p:style>
+        <p:txBody>
+          <a:bodyPr rtlCol="0" anchor="ctr"/>
+          <a:lstStyle/>
+          <a:p>
+            <a:pPr algn="ctr"/>
+          </a:p>
+        </p:txBody>
+      </p:sp>
+      <p:sp>
+        <p:nvSpPr>
+          <p:cNvPr id="59" name="TextBox 58"/>
+          <p:cNvSpPr txBox="1"/>
+          <p:nvPr/>
+        </p:nvSpPr>
+        <p:spPr>
+          <a:xfrm>
+            <a:off x="5074920" y="4379976"/>
+            <a:ext cx="2011680" cy="365760"/>
+          </a:xfrm>
+          <a:prstGeom prst="rect">
+            <a:avLst/>
+          </a:prstGeom>
+          <a:noFill/>
+        </p:spPr>
+        <p:txBody>
+          <a:bodyPr wrap="square">
+            <a:spAutoFit/>
+          </a:bodyPr>
+          <a:lstStyle/>
+          <a:p>
+            <a:pPr algn="l"/>
+            <a:r>
+              <a:rPr sz="1150" b="0" i="0">
+                <a:solidFill>
+                  <a:srgbClr val="222222"/>
+                </a:solidFill>
+                <a:latin typeface="Open Sauce"/>
+              </a:rPr>
+              <a:t>Analytics</a:t>
+            </a:r>
+          </a:p>
+        </p:txBody>
+      </p:sp>
+      <p:sp>
+        <p:nvSpPr>
+          <p:cNvPr id="60" name="Rectangle 59"/>
+          <p:cNvSpPr/>
+          <p:nvPr/>
+        </p:nvSpPr>
+        <p:spPr>
+          <a:xfrm>
+            <a:off x="7132320" y="4315968"/>
+            <a:ext cx="2606040" cy="457200"/>
+          </a:xfrm>
+          <a:prstGeom prst="rect">
+            <a:avLst/>
+          </a:prstGeom>
+          <a:solidFill>
+            <a:srgbClr val="F8F8F8"/>
+          </a:solidFill>
+          <a:ln>
+            <a:noFill/>
+          </a:ln>
+        </p:spPr>
+        <p:style>
+          <a:lnRef idx="1">
+            <a:schemeClr val="accent1"/>
+          </a:lnRef>
+          <a:fillRef idx="3">
+            <a:schemeClr val="accent1"/>
+          </a:fillRef>
+          <a:effectRef idx="2">
+            <a:schemeClr val="accent1"/>
+          </a:effectRef>
+          <a:fontRef idx="minor">
+            <a:schemeClr val="lt1"/>
+          </a:fontRef>
+        </p:style>
+        <p:txBody>
+          <a:bodyPr rtlCol="0" anchor="ctr"/>
+          <a:lstStyle/>
+          <a:p>
+            <a:pPr algn="ctr"/>
+          </a:p>
+        </p:txBody>
+      </p:sp>
+      <p:sp>
+        <p:nvSpPr>
+          <p:cNvPr id="61" name="TextBox 60"/>
+          <p:cNvSpPr txBox="1"/>
+          <p:nvPr/>
+        </p:nvSpPr>
+        <p:spPr>
+          <a:xfrm>
+            <a:off x="7223760" y="4379976"/>
+            <a:ext cx="2468880" cy="365760"/>
+          </a:xfrm>
+          <a:prstGeom prst="rect">
+            <a:avLst/>
+          </a:prstGeom>
+          <a:noFill/>
+        </p:spPr>
+        <p:txBody>
+          <a:bodyPr wrap="square">
+            <a:spAutoFit/>
+          </a:bodyPr>
+          <a:lstStyle/>
+          <a:p>
+            <a:pPr algn="l"/>
+            <a:r>
+              <a:rPr sz="1150" b="0" i="0">
+                <a:solidFill>
+                  <a:srgbClr val="222222"/>
+                </a:solidFill>
+                <a:latin typeface="Open Sauce"/>
+              </a:rPr>
+              <a:t>No single source of truth</a:t>
+            </a:r>
+          </a:p>
+        </p:txBody>
+      </p:sp>
+      <p:sp>
+        <p:nvSpPr>
+          <p:cNvPr id="62" name="Rectangle 61"/>
+          <p:cNvSpPr/>
+          <p:nvPr/>
+        </p:nvSpPr>
+        <p:spPr>
+          <a:xfrm>
+            <a:off x="502920" y="4846320"/>
             <a:ext cx="9235440" cy="420624"/>
           </a:xfrm>
           <a:prstGeom prst="rect">
@@ -17826,13 +18563,13 @@
       </p:sp>
       <p:sp>
         <p:nvSpPr>
-          <p:cNvPr id="55" name="TextBox 54"/>
-          <p:cNvSpPr txBox="1"/>
-          <p:nvPr/>
-        </p:nvSpPr>
-        <p:spPr>
-          <a:xfrm>
-            <a:off x="640080" y="4462272"/>
+          <p:cNvPr id="63" name="TextBox 62"/>
+          <p:cNvSpPr txBox="1"/>
+          <p:nvPr/>
+        </p:nvSpPr>
+        <p:spPr>
+          <a:xfrm>
+            <a:off x="640080" y="4919472"/>
             <a:ext cx="9006840" cy="310896"/>
           </a:xfrm>
           <a:prstGeom prst="rect">
@@ -17861,13 +18598,13 @@
       </p:sp>
       <p:sp>
         <p:nvSpPr>
-          <p:cNvPr id="56" name="Rectangle 55"/>
+          <p:cNvPr id="64" name="Rectangle 63"/>
           <p:cNvSpPr/>
           <p:nvPr/>
         </p:nvSpPr>
         <p:spPr>
           <a:xfrm>
-            <a:off x="502920" y="4974336"/>
+            <a:off x="502920" y="5431536"/>
             <a:ext cx="1051560" cy="594360"/>
           </a:xfrm>
           <a:prstGeom prst="rect">
@@ -17904,13 +18641,13 @@
       </p:sp>
       <p:sp>
         <p:nvSpPr>
-          <p:cNvPr id="57" name="TextBox 56"/>
-          <p:cNvSpPr txBox="1"/>
-          <p:nvPr/>
-        </p:nvSpPr>
-        <p:spPr>
-          <a:xfrm>
-            <a:off x="548640" y="5020056"/>
+          <p:cNvPr id="65" name="TextBox 64"/>
+          <p:cNvSpPr txBox="1"/>
+          <p:nvPr/>
+        </p:nvSpPr>
+        <p:spPr>
+          <a:xfrm>
+            <a:off x="548640" y="5477256"/>
             <a:ext cx="960120" cy="530352"/>
           </a:xfrm>
           <a:prstGeom prst="rect">
@@ -17939,13 +18676,13 @@
       </p:sp>
       <p:sp>
         <p:nvSpPr>
-          <p:cNvPr id="58" name="TextBox 57"/>
-          <p:cNvSpPr txBox="1"/>
-          <p:nvPr/>
-        </p:nvSpPr>
-        <p:spPr>
-          <a:xfrm>
-            <a:off x="1581912" y="5157216"/>
+          <p:cNvPr id="66" name="TextBox 65"/>
+          <p:cNvSpPr txBox="1"/>
+          <p:nvPr/>
+        </p:nvSpPr>
+        <p:spPr>
+          <a:xfrm>
+            <a:off x="1581912" y="5614416"/>
             <a:ext cx="201168" cy="256032"/>
           </a:xfrm>
           <a:prstGeom prst="rect">
@@ -17974,13 +18711,13 @@
       </p:sp>
       <p:sp>
         <p:nvSpPr>
-          <p:cNvPr id="59" name="Rectangle 58"/>
+          <p:cNvPr id="67" name="Rectangle 66"/>
           <p:cNvSpPr/>
           <p:nvPr/>
         </p:nvSpPr>
         <p:spPr>
           <a:xfrm>
-            <a:off x="1810512" y="4974336"/>
+            <a:off x="1810512" y="5431536"/>
             <a:ext cx="914400" cy="594360"/>
           </a:xfrm>
           <a:prstGeom prst="rect">
@@ -18017,13 +18754,13 @@
       </p:sp>
       <p:sp>
         <p:nvSpPr>
-          <p:cNvPr id="60" name="TextBox 59"/>
-          <p:cNvSpPr txBox="1"/>
-          <p:nvPr/>
-        </p:nvSpPr>
-        <p:spPr>
-          <a:xfrm>
-            <a:off x="1856232" y="5020056"/>
+          <p:cNvPr id="68" name="TextBox 67"/>
+          <p:cNvSpPr txBox="1"/>
+          <p:nvPr/>
+        </p:nvSpPr>
+        <p:spPr>
+          <a:xfrm>
+            <a:off x="1856232" y="5477256"/>
             <a:ext cx="822960" cy="530352"/>
           </a:xfrm>
           <a:prstGeom prst="rect">
@@ -18052,13 +18789,13 @@
       </p:sp>
       <p:sp>
         <p:nvSpPr>
-          <p:cNvPr id="61" name="Rectangle 60"/>
+          <p:cNvPr id="69" name="Rectangle 68"/>
           <p:cNvSpPr/>
           <p:nvPr/>
         </p:nvSpPr>
         <p:spPr>
           <a:xfrm>
-            <a:off x="2788920" y="4974336"/>
+            <a:off x="2788920" y="5431536"/>
             <a:ext cx="1051560" cy="594360"/>
           </a:xfrm>
           <a:prstGeom prst="rect">
@@ -18095,13 +18832,13 @@
       </p:sp>
       <p:sp>
         <p:nvSpPr>
-          <p:cNvPr id="62" name="TextBox 61"/>
-          <p:cNvSpPr txBox="1"/>
-          <p:nvPr/>
-        </p:nvSpPr>
-        <p:spPr>
-          <a:xfrm>
-            <a:off x="2834640" y="5020056"/>
+          <p:cNvPr id="70" name="TextBox 69"/>
+          <p:cNvSpPr txBox="1"/>
+          <p:nvPr/>
+        </p:nvSpPr>
+        <p:spPr>
+          <a:xfrm>
+            <a:off x="2834640" y="5477256"/>
             <a:ext cx="960120" cy="530352"/>
           </a:xfrm>
           <a:prstGeom prst="rect">
@@ -18123,20 +18860,20 @@
                 </a:solidFill>
                 <a:latin typeface="Open Sauce"/>
               </a:rPr>
-              <a:t>3 disconnected views</a:t>
-            </a:r>
-          </a:p>
-        </p:txBody>
-      </p:sp>
-      <p:sp>
-        <p:nvSpPr>
-          <p:cNvPr id="63" name="TextBox 62"/>
-          <p:cNvSpPr txBox="1"/>
-          <p:nvPr/>
-        </p:nvSpPr>
-        <p:spPr>
-          <a:xfrm>
-            <a:off x="3867912" y="5157216"/>
+              <a:t>4 disconnected views</a:t>
+            </a:r>
+          </a:p>
+        </p:txBody>
+      </p:sp>
+      <p:sp>
+        <p:nvSpPr>
+          <p:cNvPr id="71" name="TextBox 70"/>
+          <p:cNvSpPr txBox="1"/>
+          <p:nvPr/>
+        </p:nvSpPr>
+        <p:spPr>
+          <a:xfrm>
+            <a:off x="3867912" y="5614416"/>
             <a:ext cx="201168" cy="256032"/>
           </a:xfrm>
           <a:prstGeom prst="rect">
@@ -18165,13 +18902,13 @@
       </p:sp>
       <p:sp>
         <p:nvSpPr>
-          <p:cNvPr id="64" name="Rectangle 63"/>
+          <p:cNvPr id="72" name="Rectangle 71"/>
           <p:cNvSpPr/>
           <p:nvPr/>
         </p:nvSpPr>
         <p:spPr>
           <a:xfrm>
-            <a:off x="4096512" y="4974336"/>
+            <a:off x="4096512" y="5431536"/>
             <a:ext cx="914400" cy="594360"/>
           </a:xfrm>
           <a:prstGeom prst="rect">
@@ -18208,13 +18945,13 @@
       </p:sp>
       <p:sp>
         <p:nvSpPr>
-          <p:cNvPr id="65" name="TextBox 64"/>
-          <p:cNvSpPr txBox="1"/>
-          <p:nvPr/>
-        </p:nvSpPr>
-        <p:spPr>
-          <a:xfrm>
-            <a:off x="4142232" y="5020056"/>
+          <p:cNvPr id="73" name="TextBox 72"/>
+          <p:cNvSpPr txBox="1"/>
+          <p:nvPr/>
+        </p:nvSpPr>
+        <p:spPr>
+          <a:xfrm>
+            <a:off x="4142232" y="5477256"/>
             <a:ext cx="822960" cy="530352"/>
           </a:xfrm>
           <a:prstGeom prst="rect">
@@ -18243,13 +18980,13 @@
       </p:sp>
       <p:sp>
         <p:nvSpPr>
-          <p:cNvPr id="66" name="Rectangle 65"/>
+          <p:cNvPr id="74" name="Rectangle 73"/>
           <p:cNvSpPr/>
           <p:nvPr/>
         </p:nvSpPr>
         <p:spPr>
           <a:xfrm>
-            <a:off x="5074920" y="4974336"/>
+            <a:off x="5074920" y="5431536"/>
             <a:ext cx="1051560" cy="594360"/>
           </a:xfrm>
           <a:prstGeom prst="rect">
@@ -18286,13 +19023,13 @@
       </p:sp>
       <p:sp>
         <p:nvSpPr>
-          <p:cNvPr id="67" name="TextBox 66"/>
-          <p:cNvSpPr txBox="1"/>
-          <p:nvPr/>
-        </p:nvSpPr>
-        <p:spPr>
-          <a:xfrm>
-            <a:off x="5120640" y="5020056"/>
+          <p:cNvPr id="75" name="TextBox 74"/>
+          <p:cNvSpPr txBox="1"/>
+          <p:nvPr/>
+        </p:nvSpPr>
+        <p:spPr>
+          <a:xfrm>
+            <a:off x="5120640" y="5477256"/>
             <a:ext cx="960120" cy="530352"/>
           </a:xfrm>
           <a:prstGeom prst="rect">
@@ -18321,13 +19058,13 @@
       </p:sp>
       <p:sp>
         <p:nvSpPr>
-          <p:cNvPr id="68" name="TextBox 67"/>
-          <p:cNvSpPr txBox="1"/>
-          <p:nvPr/>
-        </p:nvSpPr>
-        <p:spPr>
-          <a:xfrm>
-            <a:off x="6153912" y="5157216"/>
+          <p:cNvPr id="76" name="TextBox 75"/>
+          <p:cNvSpPr txBox="1"/>
+          <p:nvPr/>
+        </p:nvSpPr>
+        <p:spPr>
+          <a:xfrm>
+            <a:off x="6153912" y="5614416"/>
             <a:ext cx="201168" cy="256032"/>
           </a:xfrm>
           <a:prstGeom prst="rect">
@@ -18356,13 +19093,13 @@
       </p:sp>
       <p:sp>
         <p:nvSpPr>
-          <p:cNvPr id="69" name="Rectangle 68"/>
+          <p:cNvPr id="77" name="Rectangle 76"/>
           <p:cNvSpPr/>
           <p:nvPr/>
         </p:nvSpPr>
         <p:spPr>
           <a:xfrm>
-            <a:off x="6382512" y="4974336"/>
+            <a:off x="6382512" y="5431536"/>
             <a:ext cx="914400" cy="594360"/>
           </a:xfrm>
           <a:prstGeom prst="rect">
@@ -18399,13 +19136,13 @@
       </p:sp>
       <p:sp>
         <p:nvSpPr>
-          <p:cNvPr id="70" name="TextBox 69"/>
-          <p:cNvSpPr txBox="1"/>
-          <p:nvPr/>
-        </p:nvSpPr>
-        <p:spPr>
-          <a:xfrm>
-            <a:off x="6428232" y="5020056"/>
+          <p:cNvPr id="78" name="TextBox 77"/>
+          <p:cNvSpPr txBox="1"/>
+          <p:nvPr/>
+        </p:nvSpPr>
+        <p:spPr>
+          <a:xfrm>
+            <a:off x="6428232" y="5477256"/>
             <a:ext cx="822960" cy="530352"/>
           </a:xfrm>
           <a:prstGeom prst="rect">
@@ -18434,13 +19171,13 @@
       </p:sp>
       <p:sp>
         <p:nvSpPr>
-          <p:cNvPr id="71" name="Rectangle 70"/>
+          <p:cNvPr id="79" name="Rectangle 78"/>
           <p:cNvSpPr/>
           <p:nvPr/>
         </p:nvSpPr>
         <p:spPr>
           <a:xfrm>
-            <a:off x="7360920" y="4974336"/>
+            <a:off x="7360920" y="5431536"/>
             <a:ext cx="1051560" cy="594360"/>
           </a:xfrm>
           <a:prstGeom prst="rect">
@@ -18477,13 +19214,13 @@
       </p:sp>
       <p:sp>
         <p:nvSpPr>
-          <p:cNvPr id="72" name="TextBox 71"/>
-          <p:cNvSpPr txBox="1"/>
-          <p:nvPr/>
-        </p:nvSpPr>
-        <p:spPr>
-          <a:xfrm>
-            <a:off x="7406640" y="5020056"/>
+          <p:cNvPr id="80" name="TextBox 79"/>
+          <p:cNvSpPr txBox="1"/>
+          <p:nvPr/>
+        </p:nvSpPr>
+        <p:spPr>
+          <a:xfrm>
+            <a:off x="7406640" y="5477256"/>
             <a:ext cx="960120" cy="530352"/>
           </a:xfrm>
           <a:prstGeom prst="rect">
@@ -18512,13 +19249,13 @@
       </p:sp>
       <p:sp>
         <p:nvSpPr>
-          <p:cNvPr id="73" name="TextBox 72"/>
-          <p:cNvSpPr txBox="1"/>
-          <p:nvPr/>
-        </p:nvSpPr>
-        <p:spPr>
-          <a:xfrm>
-            <a:off x="8439912" y="5157216"/>
+          <p:cNvPr id="81" name="TextBox 80"/>
+          <p:cNvSpPr txBox="1"/>
+          <p:nvPr/>
+        </p:nvSpPr>
+        <p:spPr>
+          <a:xfrm>
+            <a:off x="8439912" y="5614416"/>
             <a:ext cx="201168" cy="256032"/>
           </a:xfrm>
           <a:prstGeom prst="rect">
@@ -18547,13 +19284,13 @@
       </p:sp>
       <p:sp>
         <p:nvSpPr>
-          <p:cNvPr id="74" name="Rectangle 73"/>
+          <p:cNvPr id="82" name="Rectangle 81"/>
           <p:cNvSpPr/>
           <p:nvPr/>
         </p:nvSpPr>
         <p:spPr>
           <a:xfrm>
-            <a:off x="8668512" y="4974336"/>
+            <a:off x="8668512" y="5431536"/>
             <a:ext cx="914400" cy="594360"/>
           </a:xfrm>
           <a:prstGeom prst="rect">
@@ -18590,13 +19327,13 @@
       </p:sp>
       <p:sp>
         <p:nvSpPr>
-          <p:cNvPr id="75" name="TextBox 74"/>
-          <p:cNvSpPr txBox="1"/>
-          <p:nvPr/>
-        </p:nvSpPr>
-        <p:spPr>
-          <a:xfrm>
-            <a:off x="8714232" y="5020056"/>
+          <p:cNvPr id="83" name="TextBox 82"/>
+          <p:cNvSpPr txBox="1"/>
+          <p:nvPr/>
+        </p:nvSpPr>
+        <p:spPr>
+          <a:xfrm>
+            <a:off x="8714232" y="5477256"/>
             <a:ext cx="822960" cy="530352"/>
           </a:xfrm>
           <a:prstGeom prst="rect">
@@ -18625,7 +19362,7 @@
       </p:sp>
       <p:sp>
         <p:nvSpPr>
-          <p:cNvPr id="76" name="TextBox 75"/>
+          <p:cNvPr id="84" name="TextBox 83"/>
           <p:cNvSpPr txBox="1"/>
           <p:nvPr/>
         </p:nvSpPr>
@@ -18974,8 +19711,8 @@
                 <a:latin typeface="Open Sauce"/>
               </a:rPr>
               <a:t>Salesforce  ·  MySQL RDS
-Sage Intacct  ·  Sage X3
-OAuth 2.0 / REST / JWT</a:t>
+Sage Intacct  ·  Sage X3  ·  NetSuite
+OAuth 2.0 / REST / JWT / TBA</a:t>
             </a:r>
           </a:p>
         </p:txBody>
@@ -19530,7 +20267,7 @@
                 </a:solidFill>
                 <a:latin typeface="Open Sauce Bold"/>
               </a:rPr>
-              <a:t>4 sources</a:t>
+              <a:t>5 sources</a:t>
             </a:r>
           </a:p>
         </p:txBody>
@@ -20158,7 +20895,7 @@
                 </a:solidFill>
                 <a:latin typeface="Open Sauce"/>
               </a:rPr>
-              <a:t>Salesforce CRM  ·  MySQL RDS  ·  Sage Intacct  ·  Sage X3  ·  (NetSuite — roadmap)</a:t>
+              <a:t>Salesforce CRM  ·  MySQL RDS  ·  Sage Intacct  ·  Sage X3  ·  NetSuite ERP</a:t>
             </a:r>
           </a:p>
         </p:txBody>
@@ -22007,12 +22744,10 @@
             <a:avLst/>
           </a:prstGeom>
           <a:solidFill>
-            <a:srgbClr val="F8F8F8"/>
+            <a:srgbClr val="FFA500"/>
           </a:solidFill>
-          <a:ln w="12700">
-            <a:solidFill>
-              <a:srgbClr val="D0D0D0"/>
-            </a:solidFill>
+          <a:ln>
+            <a:noFill/>
           </a:ln>
         </p:spPr>
         <p:style>
@@ -22063,11 +22798,11 @@
             <a:r>
               <a:rPr sz="1800" b="0" i="0">
                 <a:solidFill>
-                  <a:srgbClr val="383E48"/>
-                </a:solidFill>
-                <a:latin typeface="Open Sauce"/>
-              </a:rPr>
-              <a:t>🔲</a:t>
+                  <a:srgbClr val="FFFFFF"/>
+                </a:solidFill>
+                <a:latin typeface="Open Sauce"/>
+              </a:rPr>
+              <a:t>✅</a:t>
             </a:r>
           </a:p>
         </p:txBody>
@@ -22098,7 +22833,7 @@
             <a:r>
               <a:rPr sz="1200" b="1" i="0">
                 <a:solidFill>
-                  <a:srgbClr val="383E48"/>
+                  <a:srgbClr val="FFFFFF"/>
                 </a:solidFill>
                 <a:latin typeface="Open Sauce Bold"/>
               </a:rPr>
@@ -22122,7 +22857,7 @@
             <a:avLst/>
           </a:prstGeom>
           <a:solidFill>
-            <a:srgbClr val="D0D0D0"/>
+            <a:srgbClr val="FFFFFF"/>
           </a:solidFill>
           <a:ln>
             <a:noFill/>
@@ -22176,14 +22911,14 @@
             <a:r>
               <a:rPr sz="1100" b="0" i="0">
                 <a:solidFill>
-                  <a:srgbClr val="666666"/>
-                </a:solidFill>
-                <a:latin typeface="Open Sauce"/>
-              </a:rPr>
-              <a:t>OAuth 1.0a token-based
-Future — config only
-No code change needed
-Credentials pre-reserved</a:t>
+                  <a:srgbClr val="EEEEEE"/>
+                </a:solidFill>
+                <a:latin typeface="Open Sauce"/>
+              </a:rPr>
+              <a:t>OAuth 1.0a TBA (HMAC-SHA256)
+SuiteQL incremental extraction
+Entity: Customer (any record type)
+Watermark: lastModifiedDate</a:t>
             </a:r>
           </a:p>
         </p:txBody>
@@ -23564,7 +24299,7 @@
         <p:spPr>
           <a:xfrm>
             <a:off x="502920" y="1664208"/>
-            <a:ext cx="2971800" cy="1874519"/>
+            <a:ext cx="2171700" cy="1874519"/>
           </a:xfrm>
           <a:prstGeom prst="rect">
             <a:avLst/>
@@ -23607,7 +24342,7 @@
         <p:spPr>
           <a:xfrm>
             <a:off x="612648" y="1755648"/>
-            <a:ext cx="2788920" cy="384048"/>
+            <a:ext cx="1988820" cy="384048"/>
           </a:xfrm>
           <a:prstGeom prst="rect">
             <a:avLst/>
@@ -23642,7 +24377,7 @@
         <p:spPr>
           <a:xfrm>
             <a:off x="612648" y="2176272"/>
-            <a:ext cx="2788920" cy="1280160"/>
+            <a:ext cx="1988820" cy="1280160"/>
           </a:xfrm>
           <a:prstGeom prst="rect">
             <a:avLst/>
@@ -23679,8 +24414,8 @@
         </p:nvSpPr>
         <p:spPr>
           <a:xfrm>
-            <a:off x="3703320" y="1664208"/>
-            <a:ext cx="2971800" cy="1874519"/>
+            <a:off x="2903220" y="1664208"/>
+            <a:ext cx="2171700" cy="1874519"/>
           </a:xfrm>
           <a:prstGeom prst="rect">
             <a:avLst/>
@@ -23722,8 +24457,8 @@
         </p:nvSpPr>
         <p:spPr>
           <a:xfrm>
-            <a:off x="3813048" y="1755648"/>
-            <a:ext cx="2788920" cy="384048"/>
+            <a:off x="3012948" y="1755648"/>
+            <a:ext cx="1988820" cy="384048"/>
           </a:xfrm>
           <a:prstGeom prst="rect">
             <a:avLst/>
@@ -23757,8 +24492,8 @@
         </p:nvSpPr>
         <p:spPr>
           <a:xfrm>
-            <a:off x="3813048" y="2176272"/>
-            <a:ext cx="2788920" cy="1280160"/>
+            <a:off x="3012948" y="2176272"/>
+            <a:ext cx="1988820" cy="1280160"/>
           </a:xfrm>
           <a:prstGeom prst="rect">
             <a:avLst/>
@@ -23795,8 +24530,8 @@
         </p:nvSpPr>
         <p:spPr>
           <a:xfrm>
-            <a:off x="6903720" y="1664208"/>
-            <a:ext cx="2971800" cy="1874519"/>
+            <a:off x="5303520" y="1664208"/>
+            <a:ext cx="2171700" cy="1874519"/>
           </a:xfrm>
           <a:prstGeom prst="rect">
             <a:avLst/>
@@ -23838,8 +24573,8 @@
         </p:nvSpPr>
         <p:spPr>
           <a:xfrm>
-            <a:off x="7013448" y="1755648"/>
-            <a:ext cx="2788920" cy="384048"/>
+            <a:off x="5413248" y="1755648"/>
+            <a:ext cx="1988820" cy="384048"/>
           </a:xfrm>
           <a:prstGeom prst="rect">
             <a:avLst/>
@@ -23873,8 +24608,8 @@
         </p:nvSpPr>
         <p:spPr>
           <a:xfrm>
-            <a:off x="7013448" y="2176272"/>
-            <a:ext cx="2788920" cy="1280160"/>
+            <a:off x="5413248" y="2176272"/>
+            <a:ext cx="1988820" cy="1280160"/>
           </a:xfrm>
           <a:prstGeom prst="rect">
             <a:avLst/>
@@ -23905,7 +24640,123 @@
       </p:sp>
       <p:sp>
         <p:nvSpPr>
-          <p:cNvPr id="15" name="TextBox 14"/>
+          <p:cNvPr id="15" name="Rectangle 14"/>
+          <p:cNvSpPr/>
+          <p:nvPr/>
+        </p:nvSpPr>
+        <p:spPr>
+          <a:xfrm>
+            <a:off x="7703820" y="1664208"/>
+            <a:ext cx="2171700" cy="1874519"/>
+          </a:xfrm>
+          <a:prstGeom prst="rect">
+            <a:avLst/>
+          </a:prstGeom>
+          <a:solidFill>
+            <a:srgbClr val="FFA500"/>
+          </a:solidFill>
+          <a:ln>
+            <a:noFill/>
+          </a:ln>
+        </p:spPr>
+        <p:style>
+          <a:lnRef idx="1">
+            <a:schemeClr val="accent1"/>
+          </a:lnRef>
+          <a:fillRef idx="3">
+            <a:schemeClr val="accent1"/>
+          </a:fillRef>
+          <a:effectRef idx="2">
+            <a:schemeClr val="accent1"/>
+          </a:effectRef>
+          <a:fontRef idx="minor">
+            <a:schemeClr val="lt1"/>
+          </a:fontRef>
+        </p:style>
+        <p:txBody>
+          <a:bodyPr rtlCol="0" anchor="ctr"/>
+          <a:lstStyle/>
+          <a:p>
+            <a:pPr algn="ctr"/>
+          </a:p>
+        </p:txBody>
+      </p:sp>
+      <p:sp>
+        <p:nvSpPr>
+          <p:cNvPr id="16" name="TextBox 15"/>
+          <p:cNvSpPr txBox="1"/>
+          <p:nvPr/>
+        </p:nvSpPr>
+        <p:spPr>
+          <a:xfrm>
+            <a:off x="7813548" y="1755648"/>
+            <a:ext cx="1988820" cy="384048"/>
+          </a:xfrm>
+          <a:prstGeom prst="rect">
+            <a:avLst/>
+          </a:prstGeom>
+          <a:noFill/>
+        </p:spPr>
+        <p:txBody>
+          <a:bodyPr wrap="square">
+            <a:spAutoFit/>
+          </a:bodyPr>
+          <a:lstStyle/>
+          <a:p>
+            <a:pPr algn="l"/>
+            <a:r>
+              <a:rPr sz="1300" b="1" i="0">
+                <a:solidFill>
+                  <a:srgbClr val="FFFFFF"/>
+                </a:solidFill>
+                <a:latin typeface="Open Sauce Bold"/>
+              </a:rPr>
+              <a:t>NetSuite Customer</a:t>
+            </a:r>
+          </a:p>
+        </p:txBody>
+      </p:sp>
+      <p:sp>
+        <p:nvSpPr>
+          <p:cNvPr id="17" name="TextBox 16"/>
+          <p:cNvSpPr txBox="1"/>
+          <p:nvPr/>
+        </p:nvSpPr>
+        <p:spPr>
+          <a:xfrm>
+            <a:off x="7813548" y="2176272"/>
+            <a:ext cx="1988820" cy="1280160"/>
+          </a:xfrm>
+          <a:prstGeom prst="rect">
+            <a:avLst/>
+          </a:prstGeom>
+          <a:noFill/>
+        </p:spPr>
+        <p:txBody>
+          <a:bodyPr wrap="square">
+            <a:spAutoFit/>
+          </a:bodyPr>
+          <a:lstStyle/>
+          <a:p>
+            <a:pPr algn="l"/>
+            <a:r>
+              <a:rPr sz="1200" b="0" i="0">
+                <a:solidFill>
+                  <a:srgbClr val="DDEEFF"/>
+                </a:solidFill>
+                <a:latin typeface="Open Sauce"/>
+              </a:rPr>
+              <a:t>customer_id
+company_name
+email_address
+full_name</a:t>
+            </a:r>
+          </a:p>
+        </p:txBody>
+      </p:sp>
+      <p:sp>
+        <p:nvSpPr>
+          <p:cNvPr id="18" name="TextBox 17"/>
           <p:cNvSpPr txBox="1"/>
           <p:nvPr/>
         </p:nvSpPr>
@@ -23940,7 +24791,7 @@
       </p:sp>
       <p:sp>
         <p:nvSpPr>
-          <p:cNvPr id="16" name="Rectangle 15"/>
+          <p:cNvPr id="19" name="Rectangle 18"/>
           <p:cNvSpPr/>
           <p:nvPr/>
         </p:nvSpPr>
@@ -23985,7 +24836,7 @@
       </p:sp>
       <p:sp>
         <p:nvSpPr>
-          <p:cNvPr id="17" name="TextBox 16"/>
+          <p:cNvPr id="20" name="TextBox 19"/>
           <p:cNvSpPr txBox="1"/>
           <p:nvPr/>
         </p:nvSpPr>
@@ -24020,7 +24871,7 @@
       </p:sp>
       <p:sp>
         <p:nvSpPr>
-          <p:cNvPr id="18" name="TextBox 17"/>
+          <p:cNvPr id="21" name="TextBox 20"/>
           <p:cNvSpPr txBox="1"/>
           <p:nvPr/>
         </p:nvSpPr>
@@ -24056,7 +24907,7 @@
       </p:sp>
       <p:sp>
         <p:nvSpPr>
-          <p:cNvPr id="19" name="TextBox 18"/>
+          <p:cNvPr id="22" name="TextBox 21"/>
           <p:cNvSpPr txBox="1"/>
           <p:nvPr/>
         </p:nvSpPr>
@@ -24127,7 +24978,7 @@
       </p:sp>
       <p:sp>
         <p:nvSpPr>
-          <p:cNvPr id="20" name="TextBox 19"/>
+          <p:cNvPr id="23" name="TextBox 22"/>
           <p:cNvSpPr txBox="1"/>
           <p:nvPr/>
         </p:nvSpPr>

</xml_diff>